<commit_message>
deck: retitle proof slides to 運行實況, soften 實證 wording
Co-Authored-By: Claude Fable 5 <noreply@anthropic.com>
</commit_message>
<xml_diff>
--- a/presentation/PatentMind_簡報.pptx
+++ b/presentation/PatentMind_簡報.pptx
@@ -4432,7 +4432,7 @@
                 <a:ea typeface="Microsoft JhengHei"/>
                 <a:cs typeface="Microsoft JhengHei"/>
               </a:rPr>
-              <a:t>· 平台整合實證</a:t>
+              <a:t>· 平台整合</a:t>
             </a:r>
           </a:p>
         </p:txBody>
@@ -5243,7 +5243,7 @@
                 <a:ea typeface="Microsoft JhengHei"/>
                 <a:cs typeface="Microsoft JhengHei"/>
               </a:rPr>
-              <a:t>· 平台整合實證</a:t>
+              <a:t>· 平台整合</a:t>
             </a:r>
           </a:p>
         </p:txBody>
@@ -6145,7 +6145,7 @@
                 <a:ea typeface="Microsoft JhengHei"/>
                 <a:cs typeface="Microsoft JhengHei"/>
               </a:rPr>
-              <a:t>· 平台整合實證</a:t>
+              <a:t>· 平台整合</a:t>
             </a:r>
           </a:p>
         </p:txBody>
@@ -6192,7 +6192,7 @@
                 <a:ea typeface="Microsoft JhengHei"/>
                 <a:cs typeface="Microsoft JhengHei"/>
               </a:rPr>
-              <a:t>實機證明 ①｜真模型分析結果</a:t>
+              <a:t>運行實況 ①｜真實模型的分析結果</a:t>
             </a:r>
           </a:p>
         </p:txBody>
@@ -7112,7 +7112,7 @@
                 <a:ea typeface="Microsoft JhengHei"/>
                 <a:cs typeface="Microsoft JhengHei"/>
               </a:rPr>
-              <a:t>· 平台整合實證</a:t>
+              <a:t>· 平台整合</a:t>
             </a:r>
           </a:p>
         </p:txBody>
@@ -7159,7 +7159,7 @@
                 <a:ea typeface="Microsoft JhengHei"/>
                 <a:cs typeface="Microsoft JhengHei"/>
               </a:rPr>
-              <a:t>實機證明 ②｜稽核鏈與服務狀態</a:t>
+              <a:t>運行實況 ②｜稽核鏈與服務狀態</a:t>
             </a:r>
           </a:p>
         </p:txBody>
@@ -9629,7 +9629,7 @@
                 <a:ea typeface="Microsoft JhengHei"/>
                 <a:cs typeface="Microsoft JhengHei"/>
               </a:rPr>
-              <a:t>平台整合實證</a:t>
+              <a:t>平台整合</a:t>
             </a:r>
           </a:p>
         </p:txBody>

</xml_diff>

<commit_message>
deck: drop circled-number suffixes from integration/runtime slide titles
Co-Authored-By: Claude Fable 5 <noreply@anthropic.com>
</commit_message>
<xml_diff>
--- a/presentation/PatentMind_簡報.pptx
+++ b/presentation/PatentMind_簡報.pptx
@@ -4479,7 +4479,7 @@
                 <a:ea typeface="Microsoft JhengHei"/>
                 <a:cs typeface="Microsoft JhengHei"/>
               </a:rPr>
-              <a:t>實機整合 ①｜digiRunner 前線閘道</a:t>
+              <a:t>實機整合｜digiRunner 前線閘道</a:t>
             </a:r>
           </a:p>
         </p:txBody>
@@ -5290,7 +5290,7 @@
                 <a:ea typeface="Microsoft JhengHei"/>
                 <a:cs typeface="Microsoft JhengHei"/>
               </a:rPr>
-              <a:t>實機整合 ②｜Dify AI 工作流</a:t>
+              <a:t>實機整合｜Dify AI 工作流</a:t>
             </a:r>
           </a:p>
         </p:txBody>
@@ -6192,7 +6192,7 @@
                 <a:ea typeface="Microsoft JhengHei"/>
                 <a:cs typeface="Microsoft JhengHei"/>
               </a:rPr>
-              <a:t>運行實況 ①｜真實模型的分析結果</a:t>
+              <a:t>運行實況｜真實模型的分析結果</a:t>
             </a:r>
           </a:p>
         </p:txBody>
@@ -7159,7 +7159,7 @@
                 <a:ea typeface="Microsoft JhengHei"/>
                 <a:cs typeface="Microsoft JhengHei"/>
               </a:rPr>
-              <a:t>運行實況 ②｜稽核鏈與服務狀態</a:t>
+              <a:t>運行實況｜稽核鏈與服務狀態</a:t>
             </a:r>
           </a:p>
         </p:txBody>

</xml_diff>